<commit_message>
feat(hsk1): buoi 02 - sua loi rot dong hoi thoai, them ghi chu phan biet 没关系/没事儿, go nhan 课文 o tieu de hoi thoai, sinh lai audio dung vi tri
Co-Authored-By: Claude Sonnet 5 <noreply@anthropic.com>
</commit_message>
<xml_diff>
--- a/output/hsk1/buoi02_chaohoi_lamquen/slide/Buoi-02-Chaohoi-Lamquen.pptx
+++ b/output/hsk1/buoi02_chaohoi_lamquen/slide/Buoi-02-Chaohoi-Lamquen.pptx
@@ -3724,11 +3724,69 @@
           </a:p>
         </p:txBody>
       </p:sp>
+      <p:pic>
+        <p:nvPicPr>
+          <p:cNvPr id="9" name="slide10.mp3">
+            <a:hlinkClick r:id="" action="ppaction://media"/>
+          </p:cNvPr>
+          <p:cNvPicPr>
+            <a:picLocks noChangeAspect="1"/>
+          </p:cNvPicPr>
+          <p:nvPr>
+            <a:videoFile r:link="rId4"/>
+            <p:extLst>
+              <p:ext uri="{DAA4B4D4-6D71-4841-9C94-3DE7FCFB9230}">
+                <p14:media xmlns:p14="http://schemas.microsoft.com/office/powerpoint/2010/main" r:embed="rId3"/>
+              </p:ext>
+            </p:extLst>
+          </p:nvPr>
+        </p:nvPicPr>
+        <p:blipFill>
+          <a:blip r:embed="rId5"/>
+          <a:stretch>
+            <a:fillRect/>
+          </a:stretch>
+        </p:blipFill>
+        <p:spPr>
+          <a:xfrm>
+            <a:off x="11076127" y="320040"/>
+            <a:ext cx="566928" cy="566928"/>
+          </a:xfrm>
+          <a:prstGeom prst="rect">
+            <a:avLst/>
+          </a:prstGeom>
+          <a:ln>
+            <a:noFill/>
+          </a:ln>
+        </p:spPr>
+      </p:pic>
     </p:spTree>
   </p:cSld>
   <p:clrMapOvr>
     <a:masterClrMapping/>
   </p:clrMapOvr>
+  <p:timing>
+    <p:tnLst>
+      <p:par>
+        <p:cTn id="1" dur="indefinite" restart="never" nodeType="tmRoot">
+          <p:childTnLst>
+            <p:video>
+              <p:cMediaNode vol="80000">
+                <p:cTn id="2" fill="hold" display="0">
+                  <p:stCondLst>
+                    <p:cond delay="indefinite"/>
+                  </p:stCondLst>
+                </p:cTn>
+                <p:tgtEl>
+                  <p:spTgt spid="9"/>
+                </p:tgtEl>
+              </p:cMediaNode>
+            </p:video>
+          </p:childTnLst>
+        </p:cTn>
+      </p:par>
+    </p:tnLst>
+  </p:timing>
 </p:sld>
 </file>
 
@@ -4326,11 +4384,69 @@
           </a:p>
         </p:txBody>
       </p:sp>
+      <p:pic>
+        <p:nvPicPr>
+          <p:cNvPr id="13" name="slide11.mp3">
+            <a:hlinkClick r:id="" action="ppaction://media"/>
+          </p:cNvPr>
+          <p:cNvPicPr>
+            <a:picLocks noChangeAspect="1"/>
+          </p:cNvPicPr>
+          <p:nvPr>
+            <a:videoFile r:link="rId5"/>
+            <p:extLst>
+              <p:ext uri="{DAA4B4D4-6D71-4841-9C94-3DE7FCFB9230}">
+                <p14:media xmlns:p14="http://schemas.microsoft.com/office/powerpoint/2010/main" r:embed="rId4"/>
+              </p:ext>
+            </p:extLst>
+          </p:nvPr>
+        </p:nvPicPr>
+        <p:blipFill>
+          <a:blip r:embed="rId6"/>
+          <a:stretch>
+            <a:fillRect/>
+          </a:stretch>
+        </p:blipFill>
+        <p:spPr>
+          <a:xfrm>
+            <a:off x="11076127" y="320040"/>
+            <a:ext cx="566928" cy="566928"/>
+          </a:xfrm>
+          <a:prstGeom prst="rect">
+            <a:avLst/>
+          </a:prstGeom>
+          <a:ln>
+            <a:noFill/>
+          </a:ln>
+        </p:spPr>
+      </p:pic>
     </p:spTree>
   </p:cSld>
   <p:clrMapOvr>
     <a:masterClrMapping/>
   </p:clrMapOvr>
+  <p:timing>
+    <p:tnLst>
+      <p:par>
+        <p:cTn id="1" dur="indefinite" restart="never" nodeType="tmRoot">
+          <p:childTnLst>
+            <p:video>
+              <p:cMediaNode vol="80000">
+                <p:cTn id="2" fill="hold" display="0">
+                  <p:stCondLst>
+                    <p:cond delay="indefinite"/>
+                  </p:stCondLst>
+                </p:cTn>
+                <p:tgtEl>
+                  <p:spTgt spid="13"/>
+                </p:tgtEl>
+              </p:cMediaNode>
+            </p:video>
+          </p:childTnLst>
+        </p:cTn>
+      </p:par>
+    </p:tnLst>
+  </p:timing>
 </p:sld>
 </file>
 
@@ -4928,11 +5044,69 @@
           </a:p>
         </p:txBody>
       </p:sp>
+      <p:pic>
+        <p:nvPicPr>
+          <p:cNvPr id="13" name="slide12.mp3">
+            <a:hlinkClick r:id="" action="ppaction://media"/>
+          </p:cNvPr>
+          <p:cNvPicPr>
+            <a:picLocks noChangeAspect="1"/>
+          </p:cNvPicPr>
+          <p:nvPr>
+            <a:videoFile r:link="rId5"/>
+            <p:extLst>
+              <p:ext uri="{DAA4B4D4-6D71-4841-9C94-3DE7FCFB9230}">
+                <p14:media xmlns:p14="http://schemas.microsoft.com/office/powerpoint/2010/main" r:embed="rId4"/>
+              </p:ext>
+            </p:extLst>
+          </p:nvPr>
+        </p:nvPicPr>
+        <p:blipFill>
+          <a:blip r:embed="rId6"/>
+          <a:stretch>
+            <a:fillRect/>
+          </a:stretch>
+        </p:blipFill>
+        <p:spPr>
+          <a:xfrm>
+            <a:off x="11076127" y="320040"/>
+            <a:ext cx="566928" cy="566928"/>
+          </a:xfrm>
+          <a:prstGeom prst="rect">
+            <a:avLst/>
+          </a:prstGeom>
+          <a:ln>
+            <a:noFill/>
+          </a:ln>
+        </p:spPr>
+      </p:pic>
     </p:spTree>
   </p:cSld>
   <p:clrMapOvr>
     <a:masterClrMapping/>
   </p:clrMapOvr>
+  <p:timing>
+    <p:tnLst>
+      <p:par>
+        <p:cTn id="1" dur="indefinite" restart="never" nodeType="tmRoot">
+          <p:childTnLst>
+            <p:video>
+              <p:cMediaNode vol="80000">
+                <p:cTn id="2" fill="hold" display="0">
+                  <p:stCondLst>
+                    <p:cond delay="indefinite"/>
+                  </p:stCondLst>
+                </p:cTn>
+                <p:tgtEl>
+                  <p:spTgt spid="13"/>
+                </p:tgtEl>
+              </p:cMediaNode>
+            </p:video>
+          </p:childTnLst>
+        </p:cTn>
+      </p:par>
+    </p:tnLst>
+  </p:timing>
 </p:sld>
 </file>
 
@@ -5387,11 +5561,108 @@
           </a:p>
         </p:txBody>
       </p:sp>
+      <p:pic>
+        <p:nvPicPr>
+          <p:cNvPr id="9" name="slide13.mp3">
+            <a:hlinkClick r:id="" action="ppaction://media"/>
+          </p:cNvPr>
+          <p:cNvPicPr>
+            <a:picLocks noChangeAspect="1"/>
+          </p:cNvPicPr>
+          <p:nvPr>
+            <a:videoFile r:link="rId4"/>
+            <p:extLst>
+              <p:ext uri="{DAA4B4D4-6D71-4841-9C94-3DE7FCFB9230}">
+                <p14:media xmlns:p14="http://schemas.microsoft.com/office/powerpoint/2010/main" r:embed="rId3"/>
+              </p:ext>
+            </p:extLst>
+          </p:nvPr>
+        </p:nvPicPr>
+        <p:blipFill>
+          <a:blip r:embed="rId5"/>
+          <a:stretch>
+            <a:fillRect/>
+          </a:stretch>
+        </p:blipFill>
+        <p:spPr>
+          <a:xfrm>
+            <a:off x="11076127" y="320040"/>
+            <a:ext cx="566928" cy="566928"/>
+          </a:xfrm>
+          <a:prstGeom prst="rect">
+            <a:avLst/>
+          </a:prstGeom>
+          <a:ln>
+            <a:noFill/>
+          </a:ln>
+        </p:spPr>
+      </p:pic>
+      <p:sp>
+        <p:nvSpPr>
+          <p:cNvPr id="10" name="TextBox 9"/>
+          <p:cNvSpPr txBox="1"/>
+          <p:nvPr/>
+        </p:nvSpPr>
+        <p:spPr>
+          <a:xfrm>
+            <a:off x="548640" y="6492240"/>
+            <a:ext cx="11094415" cy="274320"/>
+          </a:xfrm>
+          <a:prstGeom prst="rect">
+            <a:avLst/>
+          </a:prstGeom>
+          <a:noFill/>
+        </p:spPr>
+        <p:txBody>
+          <a:bodyPr wrap="square" anchor="ctr">
+            <a:spAutoFit/>
+          </a:bodyPr>
+          <a:lstStyle/>
+          <a:p>
+            <a:pPr>
+              <a:buNone/>
+            </a:pPr>
+            <a:r>
+              <a:rPr sz="1100" b="0" i="1">
+                <a:solidFill>
+                  <a:srgbClr val="6B7683"/>
+                </a:solidFill>
+                <a:latin typeface="Calibri"/>
+                <a:ea typeface="Microsoft YaHei"/>
+                <a:cs typeface="Microsoft YaHei"/>
+              </a:rPr>
+              <a:t>📖 So với 没关系 (slide trước): 没事儿 chỉ dùng với bạn bè thân — không chắc thì cứ dùng 没关系, luôn đúng!</a:t>
+            </a:r>
+          </a:p>
+        </p:txBody>
+      </p:sp>
     </p:spTree>
   </p:cSld>
   <p:clrMapOvr>
     <a:masterClrMapping/>
   </p:clrMapOvr>
+  <p:timing>
+    <p:tnLst>
+      <p:par>
+        <p:cTn id="1" dur="indefinite" restart="never" nodeType="tmRoot">
+          <p:childTnLst>
+            <p:video>
+              <p:cMediaNode vol="80000">
+                <p:cTn id="2" fill="hold" display="0">
+                  <p:stCondLst>
+                    <p:cond delay="indefinite"/>
+                  </p:stCondLst>
+                </p:cTn>
+                <p:tgtEl>
+                  <p:spTgt spid="9"/>
+                </p:tgtEl>
+              </p:cMediaNode>
+            </p:video>
+          </p:childTnLst>
+        </p:cTn>
+      </p:par>
+    </p:tnLst>
+  </p:timing>
 </p:sld>
 </file>
 
@@ -5965,11 +6236,69 @@
           </a:p>
         </p:txBody>
       </p:sp>
+      <p:pic>
+        <p:nvPicPr>
+          <p:cNvPr id="12" name="slide14.mp3">
+            <a:hlinkClick r:id="" action="ppaction://media"/>
+          </p:cNvPr>
+          <p:cNvPicPr>
+            <a:picLocks noChangeAspect="1"/>
+          </p:cNvPicPr>
+          <p:nvPr>
+            <a:videoFile r:link="rId4"/>
+            <p:extLst>
+              <p:ext uri="{DAA4B4D4-6D71-4841-9C94-3DE7FCFB9230}">
+                <p14:media xmlns:p14="http://schemas.microsoft.com/office/powerpoint/2010/main" r:embed="rId3"/>
+              </p:ext>
+            </p:extLst>
+          </p:nvPr>
+        </p:nvPicPr>
+        <p:blipFill>
+          <a:blip r:embed="rId5"/>
+          <a:stretch>
+            <a:fillRect/>
+          </a:stretch>
+        </p:blipFill>
+        <p:spPr>
+          <a:xfrm>
+            <a:off x="11076127" y="320040"/>
+            <a:ext cx="566928" cy="566928"/>
+          </a:xfrm>
+          <a:prstGeom prst="rect">
+            <a:avLst/>
+          </a:prstGeom>
+          <a:ln>
+            <a:noFill/>
+          </a:ln>
+        </p:spPr>
+      </p:pic>
     </p:spTree>
   </p:cSld>
   <p:clrMapOvr>
     <a:masterClrMapping/>
   </p:clrMapOvr>
+  <p:timing>
+    <p:tnLst>
+      <p:par>
+        <p:cTn id="1" dur="indefinite" restart="never" nodeType="tmRoot">
+          <p:childTnLst>
+            <p:video>
+              <p:cMediaNode vol="80000">
+                <p:cTn id="2" fill="hold" display="0">
+                  <p:stCondLst>
+                    <p:cond delay="indefinite"/>
+                  </p:stCondLst>
+                </p:cTn>
+                <p:tgtEl>
+                  <p:spTgt spid="12"/>
+                </p:tgtEl>
+              </p:cMediaNode>
+            </p:video>
+          </p:childTnLst>
+        </p:cTn>
+      </p:par>
+    </p:tnLst>
+  </p:timing>
 </p:sld>
 </file>
 
@@ -6543,11 +6872,69 @@
           </a:p>
         </p:txBody>
       </p:sp>
+      <p:pic>
+        <p:nvPicPr>
+          <p:cNvPr id="12" name="slide15.mp3">
+            <a:hlinkClick r:id="" action="ppaction://media"/>
+          </p:cNvPr>
+          <p:cNvPicPr>
+            <a:picLocks noChangeAspect="1"/>
+          </p:cNvPicPr>
+          <p:nvPr>
+            <a:videoFile r:link="rId4"/>
+            <p:extLst>
+              <p:ext uri="{DAA4B4D4-6D71-4841-9C94-3DE7FCFB9230}">
+                <p14:media xmlns:p14="http://schemas.microsoft.com/office/powerpoint/2010/main" r:embed="rId3"/>
+              </p:ext>
+            </p:extLst>
+          </p:nvPr>
+        </p:nvPicPr>
+        <p:blipFill>
+          <a:blip r:embed="rId5"/>
+          <a:stretch>
+            <a:fillRect/>
+          </a:stretch>
+        </p:blipFill>
+        <p:spPr>
+          <a:xfrm>
+            <a:off x="11076127" y="320040"/>
+            <a:ext cx="566928" cy="566928"/>
+          </a:xfrm>
+          <a:prstGeom prst="rect">
+            <a:avLst/>
+          </a:prstGeom>
+          <a:ln>
+            <a:noFill/>
+          </a:ln>
+        </p:spPr>
+      </p:pic>
     </p:spTree>
   </p:cSld>
   <p:clrMapOvr>
     <a:masterClrMapping/>
   </p:clrMapOvr>
+  <p:timing>
+    <p:tnLst>
+      <p:par>
+        <p:cTn id="1" dur="indefinite" restart="never" nodeType="tmRoot">
+          <p:childTnLst>
+            <p:video>
+              <p:cMediaNode vol="80000">
+                <p:cTn id="2" fill="hold" display="0">
+                  <p:stCondLst>
+                    <p:cond delay="indefinite"/>
+                  </p:stCondLst>
+                </p:cTn>
+                <p:tgtEl>
+                  <p:spTgt spid="12"/>
+                </p:tgtEl>
+              </p:cMediaNode>
+            </p:video>
+          </p:childTnLst>
+        </p:cTn>
+      </p:par>
+    </p:tnLst>
+  </p:timing>
 </p:sld>
 </file>
 
@@ -7121,11 +7508,69 @@
           </a:p>
         </p:txBody>
       </p:sp>
+      <p:pic>
+        <p:nvPicPr>
+          <p:cNvPr id="12" name="slide16.mp3">
+            <a:hlinkClick r:id="" action="ppaction://media"/>
+          </p:cNvPr>
+          <p:cNvPicPr>
+            <a:picLocks noChangeAspect="1"/>
+          </p:cNvPicPr>
+          <p:nvPr>
+            <a:videoFile r:link="rId4"/>
+            <p:extLst>
+              <p:ext uri="{DAA4B4D4-6D71-4841-9C94-3DE7FCFB9230}">
+                <p14:media xmlns:p14="http://schemas.microsoft.com/office/powerpoint/2010/main" r:embed="rId3"/>
+              </p:ext>
+            </p:extLst>
+          </p:nvPr>
+        </p:nvPicPr>
+        <p:blipFill>
+          <a:blip r:embed="rId5"/>
+          <a:stretch>
+            <a:fillRect/>
+          </a:stretch>
+        </p:blipFill>
+        <p:spPr>
+          <a:xfrm>
+            <a:off x="11076127" y="320040"/>
+            <a:ext cx="566928" cy="566928"/>
+          </a:xfrm>
+          <a:prstGeom prst="rect">
+            <a:avLst/>
+          </a:prstGeom>
+          <a:ln>
+            <a:noFill/>
+          </a:ln>
+        </p:spPr>
+      </p:pic>
     </p:spTree>
   </p:cSld>
   <p:clrMapOvr>
     <a:masterClrMapping/>
   </p:clrMapOvr>
+  <p:timing>
+    <p:tnLst>
+      <p:par>
+        <p:cTn id="1" dur="indefinite" restart="never" nodeType="tmRoot">
+          <p:childTnLst>
+            <p:video>
+              <p:cMediaNode vol="80000">
+                <p:cTn id="2" fill="hold" display="0">
+                  <p:stCondLst>
+                    <p:cond delay="indefinite"/>
+                  </p:stCondLst>
+                </p:cTn>
+                <p:tgtEl>
+                  <p:spTgt spid="12"/>
+                </p:tgtEl>
+              </p:cMediaNode>
+            </p:video>
+          </p:childTnLst>
+        </p:cTn>
+      </p:par>
+    </p:tnLst>
+  </p:timing>
 </p:sld>
 </file>
 
@@ -7723,11 +8168,69 @@
           </a:p>
         </p:txBody>
       </p:sp>
+      <p:pic>
+        <p:nvPicPr>
+          <p:cNvPr id="13" name="slide17.mp3">
+            <a:hlinkClick r:id="" action="ppaction://media"/>
+          </p:cNvPr>
+          <p:cNvPicPr>
+            <a:picLocks noChangeAspect="1"/>
+          </p:cNvPicPr>
+          <p:nvPr>
+            <a:videoFile r:link="rId5"/>
+            <p:extLst>
+              <p:ext uri="{DAA4B4D4-6D71-4841-9C94-3DE7FCFB9230}">
+                <p14:media xmlns:p14="http://schemas.microsoft.com/office/powerpoint/2010/main" r:embed="rId4"/>
+              </p:ext>
+            </p:extLst>
+          </p:nvPr>
+        </p:nvPicPr>
+        <p:blipFill>
+          <a:blip r:embed="rId6"/>
+          <a:stretch>
+            <a:fillRect/>
+          </a:stretch>
+        </p:blipFill>
+        <p:spPr>
+          <a:xfrm>
+            <a:off x="11076127" y="320040"/>
+            <a:ext cx="566928" cy="566928"/>
+          </a:xfrm>
+          <a:prstGeom prst="rect">
+            <a:avLst/>
+          </a:prstGeom>
+          <a:ln>
+            <a:noFill/>
+          </a:ln>
+        </p:spPr>
+      </p:pic>
     </p:spTree>
   </p:cSld>
   <p:clrMapOvr>
     <a:masterClrMapping/>
   </p:clrMapOvr>
+  <p:timing>
+    <p:tnLst>
+      <p:par>
+        <p:cTn id="1" dur="indefinite" restart="never" nodeType="tmRoot">
+          <p:childTnLst>
+            <p:video>
+              <p:cMediaNode vol="80000">
+                <p:cTn id="2" fill="hold" display="0">
+                  <p:stCondLst>
+                    <p:cond delay="indefinite"/>
+                  </p:stCondLst>
+                </p:cTn>
+                <p:tgtEl>
+                  <p:spTgt spid="13"/>
+                </p:tgtEl>
+              </p:cMediaNode>
+            </p:video>
+          </p:childTnLst>
+        </p:cTn>
+      </p:par>
+    </p:tnLst>
+  </p:timing>
 </p:sld>
 </file>
 
@@ -8277,11 +8780,69 @@
           </a:p>
         </p:txBody>
       </p:sp>
+      <p:pic>
+        <p:nvPicPr>
+          <p:cNvPr id="11" name="slide18.mp3">
+            <a:hlinkClick r:id="" action="ppaction://media"/>
+          </p:cNvPr>
+          <p:cNvPicPr>
+            <a:picLocks noChangeAspect="1"/>
+          </p:cNvPicPr>
+          <p:nvPr>
+            <a:videoFile r:link="rId3"/>
+            <p:extLst>
+              <p:ext uri="{DAA4B4D4-6D71-4841-9C94-3DE7FCFB9230}">
+                <p14:media xmlns:p14="http://schemas.microsoft.com/office/powerpoint/2010/main" r:embed="rId2"/>
+              </p:ext>
+            </p:extLst>
+          </p:nvPr>
+        </p:nvPicPr>
+        <p:blipFill>
+          <a:blip r:embed="rId4"/>
+          <a:stretch>
+            <a:fillRect/>
+          </a:stretch>
+        </p:blipFill>
+        <p:spPr>
+          <a:xfrm>
+            <a:off x="11076127" y="320040"/>
+            <a:ext cx="566928" cy="566928"/>
+          </a:xfrm>
+          <a:prstGeom prst="rect">
+            <a:avLst/>
+          </a:prstGeom>
+          <a:ln>
+            <a:noFill/>
+          </a:ln>
+        </p:spPr>
+      </p:pic>
     </p:spTree>
   </p:cSld>
   <p:clrMapOvr>
     <a:masterClrMapping/>
   </p:clrMapOvr>
+  <p:timing>
+    <p:tnLst>
+      <p:par>
+        <p:cTn id="1" dur="indefinite" restart="never" nodeType="tmRoot">
+          <p:childTnLst>
+            <p:video>
+              <p:cMediaNode vol="80000">
+                <p:cTn id="2" fill="hold" display="0">
+                  <p:stCondLst>
+                    <p:cond delay="indefinite"/>
+                  </p:stCondLst>
+                </p:cTn>
+                <p:tgtEl>
+                  <p:spTgt spid="11"/>
+                </p:tgtEl>
+              </p:cMediaNode>
+            </p:video>
+          </p:childTnLst>
+        </p:cTn>
+      </p:par>
+    </p:tnLst>
+  </p:timing>
 </p:sld>
 </file>
 
@@ -8474,7 +9035,7 @@
                 <a:ea typeface="Microsoft YaHei"/>
                 <a:cs typeface="Microsoft YaHei"/>
               </a:rPr>
-              <a:t>会话 1 — 课文1 (Bài 1)</a:t>
+              <a:t>会话 1</a:t>
             </a:r>
           </a:p>
         </p:txBody>
@@ -8488,7 +9049,7 @@
         <p:spPr>
           <a:xfrm>
             <a:off x="548640" y="1611376"/>
-            <a:ext cx="3280664" cy="1005840"/>
+            <a:ext cx="4205224" cy="1005840"/>
           </a:xfrm>
           <a:prstGeom prst="roundRect">
             <a:avLst/>
@@ -8632,8 +9193,8 @@
         </p:nvSpPr>
         <p:spPr>
           <a:xfrm>
-            <a:off x="8675319" y="2763520"/>
-            <a:ext cx="2967736" cy="1005840"/>
+            <a:off x="7935671" y="2763520"/>
+            <a:ext cx="3707384" cy="1005840"/>
           </a:xfrm>
           <a:prstGeom prst="roundRect">
             <a:avLst/>
@@ -8769,11 +9330,69 @@
           </a:p>
         </p:txBody>
       </p:sp>
+      <p:pic>
+        <p:nvPicPr>
+          <p:cNvPr id="10" name="slide19.mp3">
+            <a:hlinkClick r:id="" action="ppaction://media"/>
+          </p:cNvPr>
+          <p:cNvPicPr>
+            <a:picLocks noChangeAspect="1"/>
+          </p:cNvPicPr>
+          <p:nvPr>
+            <a:videoFile r:link="rId3"/>
+            <p:extLst>
+              <p:ext uri="{DAA4B4D4-6D71-4841-9C94-3DE7FCFB9230}">
+                <p14:media xmlns:p14="http://schemas.microsoft.com/office/powerpoint/2010/main" r:embed="rId2"/>
+              </p:ext>
+            </p:extLst>
+          </p:nvPr>
+        </p:nvPicPr>
+        <p:blipFill>
+          <a:blip r:embed="rId4"/>
+          <a:stretch>
+            <a:fillRect/>
+          </a:stretch>
+        </p:blipFill>
+        <p:spPr>
+          <a:xfrm>
+            <a:off x="11076127" y="320040"/>
+            <a:ext cx="566928" cy="566928"/>
+          </a:xfrm>
+          <a:prstGeom prst="rect">
+            <a:avLst/>
+          </a:prstGeom>
+          <a:ln>
+            <a:noFill/>
+          </a:ln>
+        </p:spPr>
+      </p:pic>
     </p:spTree>
   </p:cSld>
   <p:clrMapOvr>
     <a:masterClrMapping/>
   </p:clrMapOvr>
+  <p:timing>
+    <p:tnLst>
+      <p:par>
+        <p:cTn id="1" dur="indefinite" restart="never" nodeType="tmRoot">
+          <p:childTnLst>
+            <p:video>
+              <p:cMediaNode vol="80000">
+                <p:cTn id="2" fill="hold" display="0">
+                  <p:stCondLst>
+                    <p:cond delay="indefinite"/>
+                  </p:stCondLst>
+                </p:cTn>
+                <p:tgtEl>
+                  <p:spTgt spid="10"/>
+                </p:tgtEl>
+              </p:cMediaNode>
+            </p:video>
+          </p:childTnLst>
+        </p:cTn>
+      </p:par>
+    </p:tnLst>
+  </p:timing>
 </p:sld>
 </file>
 
@@ -9365,7 +9984,7 @@
                 <a:ea typeface="Microsoft YaHei"/>
                 <a:cs typeface="Microsoft YaHei"/>
               </a:rPr>
-              <a:t>会话 2a — 课文2 (Bài 1)</a:t>
+              <a:t>会话 2a</a:t>
             </a:r>
           </a:p>
         </p:txBody>
@@ -9379,7 +9998,7 @@
         <p:spPr>
           <a:xfrm>
             <a:off x="548640" y="1611376"/>
-            <a:ext cx="2028952" cy="1005840"/>
+            <a:ext cx="2953512" cy="1005840"/>
           </a:xfrm>
           <a:prstGeom prst="roundRect">
             <a:avLst/>
@@ -9523,8 +10142,8 @@
         </p:nvSpPr>
         <p:spPr>
           <a:xfrm>
-            <a:off x="8988247" y="2763520"/>
-            <a:ext cx="2654808" cy="1005840"/>
+            <a:off x="8063687" y="2763520"/>
+            <a:ext cx="3579368" cy="1005840"/>
           </a:xfrm>
           <a:prstGeom prst="roundRect">
             <a:avLst/>
@@ -9660,11 +10279,69 @@
           </a:p>
         </p:txBody>
       </p:sp>
+      <p:pic>
+        <p:nvPicPr>
+          <p:cNvPr id="10" name="slide20.mp3">
+            <a:hlinkClick r:id="" action="ppaction://media"/>
+          </p:cNvPr>
+          <p:cNvPicPr>
+            <a:picLocks noChangeAspect="1"/>
+          </p:cNvPicPr>
+          <p:nvPr>
+            <a:videoFile r:link="rId3"/>
+            <p:extLst>
+              <p:ext uri="{DAA4B4D4-6D71-4841-9C94-3DE7FCFB9230}">
+                <p14:media xmlns:p14="http://schemas.microsoft.com/office/powerpoint/2010/main" r:embed="rId2"/>
+              </p:ext>
+            </p:extLst>
+          </p:nvPr>
+        </p:nvPicPr>
+        <p:blipFill>
+          <a:blip r:embed="rId4"/>
+          <a:stretch>
+            <a:fillRect/>
+          </a:stretch>
+        </p:blipFill>
+        <p:spPr>
+          <a:xfrm>
+            <a:off x="11076127" y="320040"/>
+            <a:ext cx="566928" cy="566928"/>
+          </a:xfrm>
+          <a:prstGeom prst="rect">
+            <a:avLst/>
+          </a:prstGeom>
+          <a:ln>
+            <a:noFill/>
+          </a:ln>
+        </p:spPr>
+      </p:pic>
     </p:spTree>
   </p:cSld>
   <p:clrMapOvr>
     <a:masterClrMapping/>
   </p:clrMapOvr>
+  <p:timing>
+    <p:tnLst>
+      <p:par>
+        <p:cTn id="1" dur="indefinite" restart="never" nodeType="tmRoot">
+          <p:childTnLst>
+            <p:video>
+              <p:cMediaNode vol="80000">
+                <p:cTn id="2" fill="hold" display="0">
+                  <p:stCondLst>
+                    <p:cond delay="indefinite"/>
+                  </p:stCondLst>
+                </p:cTn>
+                <p:tgtEl>
+                  <p:spTgt spid="10"/>
+                </p:tgtEl>
+              </p:cMediaNode>
+            </p:video>
+          </p:childTnLst>
+        </p:cTn>
+      </p:par>
+    </p:tnLst>
+  </p:timing>
 </p:sld>
 </file>
 
@@ -9857,7 +10534,7 @@
                 <a:ea typeface="Microsoft YaHei"/>
                 <a:cs typeface="Microsoft YaHei"/>
               </a:rPr>
-              <a:t>会话 2b — 课文2 (Bài 1)</a:t>
+              <a:t>会话 2b</a:t>
             </a:r>
           </a:p>
         </p:txBody>
@@ -9871,7 +10548,7 @@
         <p:spPr>
           <a:xfrm>
             <a:off x="548640" y="1611376"/>
-            <a:ext cx="2028952" cy="1005840"/>
+            <a:ext cx="2768600" cy="1005840"/>
           </a:xfrm>
           <a:prstGeom prst="roundRect">
             <a:avLst/>
@@ -10015,8 +10692,8 @@
         </p:nvSpPr>
         <p:spPr>
           <a:xfrm>
-            <a:off x="8988247" y="2763520"/>
-            <a:ext cx="2654808" cy="1005840"/>
+            <a:off x="8063687" y="2763520"/>
+            <a:ext cx="3579368" cy="1005840"/>
           </a:xfrm>
           <a:prstGeom prst="roundRect">
             <a:avLst/>
@@ -10152,11 +10829,69 @@
           </a:p>
         </p:txBody>
       </p:sp>
+      <p:pic>
+        <p:nvPicPr>
+          <p:cNvPr id="10" name="slide21.mp3">
+            <a:hlinkClick r:id="" action="ppaction://media"/>
+          </p:cNvPr>
+          <p:cNvPicPr>
+            <a:picLocks noChangeAspect="1"/>
+          </p:cNvPicPr>
+          <p:nvPr>
+            <a:videoFile r:link="rId3"/>
+            <p:extLst>
+              <p:ext uri="{DAA4B4D4-6D71-4841-9C94-3DE7FCFB9230}">
+                <p14:media xmlns:p14="http://schemas.microsoft.com/office/powerpoint/2010/main" r:embed="rId2"/>
+              </p:ext>
+            </p:extLst>
+          </p:nvPr>
+        </p:nvPicPr>
+        <p:blipFill>
+          <a:blip r:embed="rId4"/>
+          <a:stretch>
+            <a:fillRect/>
+          </a:stretch>
+        </p:blipFill>
+        <p:spPr>
+          <a:xfrm>
+            <a:off x="11076127" y="320040"/>
+            <a:ext cx="566928" cy="566928"/>
+          </a:xfrm>
+          <a:prstGeom prst="rect">
+            <a:avLst/>
+          </a:prstGeom>
+          <a:ln>
+            <a:noFill/>
+          </a:ln>
+        </p:spPr>
+      </p:pic>
     </p:spTree>
   </p:cSld>
   <p:clrMapOvr>
     <a:masterClrMapping/>
   </p:clrMapOvr>
+  <p:timing>
+    <p:tnLst>
+      <p:par>
+        <p:cTn id="1" dur="indefinite" restart="never" nodeType="tmRoot">
+          <p:childTnLst>
+            <p:video>
+              <p:cMediaNode vol="80000">
+                <p:cTn id="2" fill="hold" display="0">
+                  <p:stCondLst>
+                    <p:cond delay="indefinite"/>
+                  </p:stCondLst>
+                </p:cTn>
+                <p:tgtEl>
+                  <p:spTgt spid="10"/>
+                </p:tgtEl>
+              </p:cMediaNode>
+            </p:video>
+          </p:childTnLst>
+        </p:cTn>
+      </p:par>
+    </p:tnLst>
+  </p:timing>
 </p:sld>
 </file>
 
@@ -10349,7 +11084,7 @@
                 <a:ea typeface="Microsoft YaHei"/>
                 <a:cs typeface="Microsoft YaHei"/>
               </a:rPr>
-              <a:t>会话 3a — 课文3 (Bài 1)</a:t>
+              <a:t>会话 3a</a:t>
             </a:r>
           </a:p>
         </p:txBody>
@@ -10363,7 +11098,7 @@
         <p:spPr>
           <a:xfrm>
             <a:off x="548640" y="1611376"/>
-            <a:ext cx="1737360" cy="1005840"/>
+            <a:ext cx="2640584" cy="1005840"/>
           </a:xfrm>
           <a:prstGeom prst="roundRect">
             <a:avLst/>
@@ -10507,8 +11242,8 @@
         </p:nvSpPr>
         <p:spPr>
           <a:xfrm>
-            <a:off x="9614103" y="2763520"/>
-            <a:ext cx="2028952" cy="1005840"/>
+            <a:off x="8874455" y="2763520"/>
+            <a:ext cx="2768600" cy="1005840"/>
           </a:xfrm>
           <a:prstGeom prst="roundRect">
             <a:avLst/>
@@ -10644,11 +11379,69 @@
           </a:p>
         </p:txBody>
       </p:sp>
+      <p:pic>
+        <p:nvPicPr>
+          <p:cNvPr id="10" name="slide22.mp3">
+            <a:hlinkClick r:id="" action="ppaction://media"/>
+          </p:cNvPr>
+          <p:cNvPicPr>
+            <a:picLocks noChangeAspect="1"/>
+          </p:cNvPicPr>
+          <p:nvPr>
+            <a:videoFile r:link="rId3"/>
+            <p:extLst>
+              <p:ext uri="{DAA4B4D4-6D71-4841-9C94-3DE7FCFB9230}">
+                <p14:media xmlns:p14="http://schemas.microsoft.com/office/powerpoint/2010/main" r:embed="rId2"/>
+              </p:ext>
+            </p:extLst>
+          </p:nvPr>
+        </p:nvPicPr>
+        <p:blipFill>
+          <a:blip r:embed="rId4"/>
+          <a:stretch>
+            <a:fillRect/>
+          </a:stretch>
+        </p:blipFill>
+        <p:spPr>
+          <a:xfrm>
+            <a:off x="11076127" y="320040"/>
+            <a:ext cx="566928" cy="566928"/>
+          </a:xfrm>
+          <a:prstGeom prst="rect">
+            <a:avLst/>
+          </a:prstGeom>
+          <a:ln>
+            <a:noFill/>
+          </a:ln>
+        </p:spPr>
+      </p:pic>
     </p:spTree>
   </p:cSld>
   <p:clrMapOvr>
     <a:masterClrMapping/>
   </p:clrMapOvr>
+  <p:timing>
+    <p:tnLst>
+      <p:par>
+        <p:cTn id="1" dur="indefinite" restart="never" nodeType="tmRoot">
+          <p:childTnLst>
+            <p:video>
+              <p:cMediaNode vol="80000">
+                <p:cTn id="2" fill="hold" display="0">
+                  <p:stCondLst>
+                    <p:cond delay="indefinite"/>
+                  </p:stCondLst>
+                </p:cTn>
+                <p:tgtEl>
+                  <p:spTgt spid="10"/>
+                </p:tgtEl>
+              </p:cMediaNode>
+            </p:video>
+          </p:childTnLst>
+        </p:cTn>
+      </p:par>
+    </p:tnLst>
+  </p:timing>
 </p:sld>
 </file>
 
@@ -10841,7 +11634,7 @@
                 <a:ea typeface="Microsoft YaHei"/>
                 <a:cs typeface="Microsoft YaHei"/>
               </a:rPr>
-              <a:t>会话 3b — 课文3 (Bài 1)</a:t>
+              <a:t>会话 3b</a:t>
             </a:r>
           </a:p>
         </p:txBody>
@@ -10855,7 +11648,7 @@
         <p:spPr>
           <a:xfrm>
             <a:off x="548640" y="1611376"/>
-            <a:ext cx="2967736" cy="1005840"/>
+            <a:ext cx="3892296" cy="1005840"/>
           </a:xfrm>
           <a:prstGeom prst="roundRect">
             <a:avLst/>
@@ -10999,8 +11792,8 @@
         </p:nvSpPr>
         <p:spPr>
           <a:xfrm>
-            <a:off x="8988247" y="2763520"/>
-            <a:ext cx="2654808" cy="1005840"/>
+            <a:off x="8063687" y="2763520"/>
+            <a:ext cx="3579368" cy="1005840"/>
           </a:xfrm>
           <a:prstGeom prst="roundRect">
             <a:avLst/>
@@ -11136,11 +11929,69 @@
           </a:p>
         </p:txBody>
       </p:sp>
+      <p:pic>
+        <p:nvPicPr>
+          <p:cNvPr id="10" name="slide23.mp3">
+            <a:hlinkClick r:id="" action="ppaction://media"/>
+          </p:cNvPr>
+          <p:cNvPicPr>
+            <a:picLocks noChangeAspect="1"/>
+          </p:cNvPicPr>
+          <p:nvPr>
+            <a:videoFile r:link="rId3"/>
+            <p:extLst>
+              <p:ext uri="{DAA4B4D4-6D71-4841-9C94-3DE7FCFB9230}">
+                <p14:media xmlns:p14="http://schemas.microsoft.com/office/powerpoint/2010/main" r:embed="rId2"/>
+              </p:ext>
+            </p:extLst>
+          </p:nvPr>
+        </p:nvPicPr>
+        <p:blipFill>
+          <a:blip r:embed="rId4"/>
+          <a:stretch>
+            <a:fillRect/>
+          </a:stretch>
+        </p:blipFill>
+        <p:spPr>
+          <a:xfrm>
+            <a:off x="11076127" y="320040"/>
+            <a:ext cx="566928" cy="566928"/>
+          </a:xfrm>
+          <a:prstGeom prst="rect">
+            <a:avLst/>
+          </a:prstGeom>
+          <a:ln>
+            <a:noFill/>
+          </a:ln>
+        </p:spPr>
+      </p:pic>
     </p:spTree>
   </p:cSld>
   <p:clrMapOvr>
     <a:masterClrMapping/>
   </p:clrMapOvr>
+  <p:timing>
+    <p:tnLst>
+      <p:par>
+        <p:cTn id="1" dur="indefinite" restart="never" nodeType="tmRoot">
+          <p:childTnLst>
+            <p:video>
+              <p:cMediaNode vol="80000">
+                <p:cTn id="2" fill="hold" display="0">
+                  <p:stCondLst>
+                    <p:cond delay="indefinite"/>
+                  </p:stCondLst>
+                </p:cTn>
+                <p:tgtEl>
+                  <p:spTgt spid="10"/>
+                </p:tgtEl>
+              </p:cMediaNode>
+            </p:video>
+          </p:childTnLst>
+        </p:cTn>
+      </p:par>
+    </p:tnLst>
+  </p:timing>
 </p:sld>
 </file>
 
@@ -11333,7 +12184,7 @@
                 <a:ea typeface="Microsoft YaHei"/>
                 <a:cs typeface="Microsoft YaHei"/>
               </a:rPr>
-              <a:t>会话 4 — 课文1 (Bài 2)</a:t>
+              <a:t>会话 4</a:t>
             </a:r>
           </a:p>
         </p:txBody>
@@ -11347,7 +12198,7 @@
         <p:spPr>
           <a:xfrm>
             <a:off x="548640" y="1611376"/>
-            <a:ext cx="3906520" cy="1005840"/>
+            <a:ext cx="4831080" cy="1005840"/>
           </a:xfrm>
           <a:prstGeom prst="roundRect">
             <a:avLst/>
@@ -11491,8 +12342,8 @@
         </p:nvSpPr>
         <p:spPr>
           <a:xfrm>
-            <a:off x="8616645" y="2763520"/>
-            <a:ext cx="3026410" cy="1005840"/>
+            <a:off x="8063687" y="2763520"/>
+            <a:ext cx="3579368" cy="1005840"/>
           </a:xfrm>
           <a:prstGeom prst="roundRect">
             <a:avLst/>
@@ -11628,11 +12479,69 @@
           </a:p>
         </p:txBody>
       </p:sp>
+      <p:pic>
+        <p:nvPicPr>
+          <p:cNvPr id="10" name="slide24.mp3">
+            <a:hlinkClick r:id="" action="ppaction://media"/>
+          </p:cNvPr>
+          <p:cNvPicPr>
+            <a:picLocks noChangeAspect="1"/>
+          </p:cNvPicPr>
+          <p:nvPr>
+            <a:videoFile r:link="rId3"/>
+            <p:extLst>
+              <p:ext uri="{DAA4B4D4-6D71-4841-9C94-3DE7FCFB9230}">
+                <p14:media xmlns:p14="http://schemas.microsoft.com/office/powerpoint/2010/main" r:embed="rId2"/>
+              </p:ext>
+            </p:extLst>
+          </p:nvPr>
+        </p:nvPicPr>
+        <p:blipFill>
+          <a:blip r:embed="rId4"/>
+          <a:stretch>
+            <a:fillRect/>
+          </a:stretch>
+        </p:blipFill>
+        <p:spPr>
+          <a:xfrm>
+            <a:off x="11076127" y="320040"/>
+            <a:ext cx="566928" cy="566928"/>
+          </a:xfrm>
+          <a:prstGeom prst="rect">
+            <a:avLst/>
+          </a:prstGeom>
+          <a:ln>
+            <a:noFill/>
+          </a:ln>
+        </p:spPr>
+      </p:pic>
     </p:spTree>
   </p:cSld>
   <p:clrMapOvr>
     <a:masterClrMapping/>
   </p:clrMapOvr>
+  <p:timing>
+    <p:tnLst>
+      <p:par>
+        <p:cTn id="1" dur="indefinite" restart="never" nodeType="tmRoot">
+          <p:childTnLst>
+            <p:video>
+              <p:cMediaNode vol="80000">
+                <p:cTn id="2" fill="hold" display="0">
+                  <p:stCondLst>
+                    <p:cond delay="indefinite"/>
+                  </p:stCondLst>
+                </p:cTn>
+                <p:tgtEl>
+                  <p:spTgt spid="10"/>
+                </p:tgtEl>
+              </p:cMediaNode>
+            </p:video>
+          </p:childTnLst>
+        </p:cTn>
+      </p:par>
+    </p:tnLst>
+  </p:timing>
 </p:sld>
 </file>
 
@@ -11825,7 +12734,7 @@
                 <a:ea typeface="Microsoft YaHei"/>
                 <a:cs typeface="Microsoft YaHei"/>
               </a:rPr>
-              <a:t>会话 5 — 课文2 (Bài 2)</a:t>
+              <a:t>会话 5</a:t>
             </a:r>
           </a:p>
         </p:txBody>
@@ -11839,7 +12748,7 @@
         <p:spPr>
           <a:xfrm>
             <a:off x="548640" y="1611376"/>
-            <a:ext cx="2398776" cy="890802"/>
+            <a:ext cx="3181096" cy="890802"/>
           </a:xfrm>
           <a:prstGeom prst="roundRect">
             <a:avLst/>
@@ -11983,8 +12892,8 @@
         </p:nvSpPr>
         <p:spPr>
           <a:xfrm>
-            <a:off x="8937955" y="2631749"/>
-            <a:ext cx="2705100" cy="890802"/>
+            <a:off x="8191703" y="2631749"/>
+            <a:ext cx="3451352" cy="890802"/>
           </a:xfrm>
           <a:prstGeom prst="roundRect">
             <a:avLst/>
@@ -12128,8 +13037,8 @@
         </p:nvSpPr>
         <p:spPr>
           <a:xfrm>
-            <a:off x="7622743" y="3652122"/>
-            <a:ext cx="4020312" cy="890802"/>
+            <a:off x="6840423" y="3652122"/>
+            <a:ext cx="4802632" cy="890802"/>
           </a:xfrm>
           <a:prstGeom prst="roundRect">
             <a:avLst/>
@@ -12274,7 +13183,7 @@
         <p:spPr>
           <a:xfrm>
             <a:off x="548640" y="4672495"/>
-            <a:ext cx="1858264" cy="890802"/>
+            <a:ext cx="2640584" cy="890802"/>
           </a:xfrm>
           <a:prstGeom prst="roundRect">
             <a:avLst/>
@@ -12418,8 +13327,8 @@
         </p:nvSpPr>
         <p:spPr>
           <a:xfrm>
-            <a:off x="9784791" y="5692868"/>
-            <a:ext cx="1858264" cy="890802"/>
+            <a:off x="9002471" y="5692868"/>
+            <a:ext cx="2640584" cy="890802"/>
           </a:xfrm>
           <a:prstGeom prst="roundRect">
             <a:avLst/>
@@ -12555,11 +13464,69 @@
           </a:p>
         </p:txBody>
       </p:sp>
+      <p:pic>
+        <p:nvPicPr>
+          <p:cNvPr id="16" name="slide25.mp3">
+            <a:hlinkClick r:id="" action="ppaction://media"/>
+          </p:cNvPr>
+          <p:cNvPicPr>
+            <a:picLocks noChangeAspect="1"/>
+          </p:cNvPicPr>
+          <p:nvPr>
+            <a:videoFile r:link="rId3"/>
+            <p:extLst>
+              <p:ext uri="{DAA4B4D4-6D71-4841-9C94-3DE7FCFB9230}">
+                <p14:media xmlns:p14="http://schemas.microsoft.com/office/powerpoint/2010/main" r:embed="rId2"/>
+              </p:ext>
+            </p:extLst>
+          </p:nvPr>
+        </p:nvPicPr>
+        <p:blipFill>
+          <a:blip r:embed="rId4"/>
+          <a:stretch>
+            <a:fillRect/>
+          </a:stretch>
+        </p:blipFill>
+        <p:spPr>
+          <a:xfrm>
+            <a:off x="11076127" y="320040"/>
+            <a:ext cx="566928" cy="566928"/>
+          </a:xfrm>
+          <a:prstGeom prst="rect">
+            <a:avLst/>
+          </a:prstGeom>
+          <a:ln>
+            <a:noFill/>
+          </a:ln>
+        </p:spPr>
+      </p:pic>
     </p:spTree>
   </p:cSld>
   <p:clrMapOvr>
     <a:masterClrMapping/>
   </p:clrMapOvr>
+  <p:timing>
+    <p:tnLst>
+      <p:par>
+        <p:cTn id="1" dur="indefinite" restart="never" nodeType="tmRoot">
+          <p:childTnLst>
+            <p:video>
+              <p:cMediaNode vol="80000">
+                <p:cTn id="2" fill="hold" display="0">
+                  <p:stCondLst>
+                    <p:cond delay="indefinite"/>
+                  </p:stCondLst>
+                </p:cTn>
+                <p:tgtEl>
+                  <p:spTgt spid="16"/>
+                </p:tgtEl>
+              </p:cMediaNode>
+            </p:video>
+          </p:childTnLst>
+        </p:cTn>
+      </p:par>
+    </p:tnLst>
+  </p:timing>
 </p:sld>
 </file>
 
@@ -12752,7 +13719,7 @@
                 <a:ea typeface="Microsoft YaHei"/>
                 <a:cs typeface="Microsoft YaHei"/>
               </a:rPr>
-              <a:t>会话 6 — 课文3 (Bài 2)</a:t>
+              <a:t>会话 6</a:t>
             </a:r>
           </a:p>
         </p:txBody>
@@ -12766,7 +13733,7 @@
         <p:spPr>
           <a:xfrm>
             <a:off x="548640" y="1611376"/>
-            <a:ext cx="3280664" cy="1005840"/>
+            <a:ext cx="4020312" cy="1005840"/>
           </a:xfrm>
           <a:prstGeom prst="roundRect">
             <a:avLst/>
@@ -12910,8 +13877,8 @@
         </p:nvSpPr>
         <p:spPr>
           <a:xfrm>
-            <a:off x="8049463" y="2763520"/>
-            <a:ext cx="3593592" cy="1005840"/>
+            <a:off x="7124903" y="2763520"/>
+            <a:ext cx="4518152" cy="1005840"/>
           </a:xfrm>
           <a:prstGeom prst="roundRect">
             <a:avLst/>
@@ -13056,7 +14023,7 @@
         <p:spPr>
           <a:xfrm>
             <a:off x="548640" y="3915664"/>
-            <a:ext cx="2967736" cy="1005840"/>
+            <a:ext cx="3707384" cy="1005840"/>
           </a:xfrm>
           <a:prstGeom prst="roundRect">
             <a:avLst/>
@@ -13200,8 +14167,8 @@
         </p:nvSpPr>
         <p:spPr>
           <a:xfrm>
-            <a:off x="8049463" y="5067808"/>
-            <a:ext cx="3593592" cy="1005840"/>
+            <a:off x="7124903" y="5067808"/>
+            <a:ext cx="4518152" cy="1005840"/>
           </a:xfrm>
           <a:prstGeom prst="roundRect">
             <a:avLst/>
@@ -13337,11 +14304,69 @@
           </a:p>
         </p:txBody>
       </p:sp>
+      <p:pic>
+        <p:nvPicPr>
+          <p:cNvPr id="14" name="slide26.mp3">
+            <a:hlinkClick r:id="" action="ppaction://media"/>
+          </p:cNvPr>
+          <p:cNvPicPr>
+            <a:picLocks noChangeAspect="1"/>
+          </p:cNvPicPr>
+          <p:nvPr>
+            <a:videoFile r:link="rId3"/>
+            <p:extLst>
+              <p:ext uri="{DAA4B4D4-6D71-4841-9C94-3DE7FCFB9230}">
+                <p14:media xmlns:p14="http://schemas.microsoft.com/office/powerpoint/2010/main" r:embed="rId2"/>
+              </p:ext>
+            </p:extLst>
+          </p:nvPr>
+        </p:nvPicPr>
+        <p:blipFill>
+          <a:blip r:embed="rId4"/>
+          <a:stretch>
+            <a:fillRect/>
+          </a:stretch>
+        </p:blipFill>
+        <p:spPr>
+          <a:xfrm>
+            <a:off x="11076127" y="320040"/>
+            <a:ext cx="566928" cy="566928"/>
+          </a:xfrm>
+          <a:prstGeom prst="rect">
+            <a:avLst/>
+          </a:prstGeom>
+          <a:ln>
+            <a:noFill/>
+          </a:ln>
+        </p:spPr>
+      </p:pic>
     </p:spTree>
   </p:cSld>
   <p:clrMapOvr>
     <a:masterClrMapping/>
   </p:clrMapOvr>
+  <p:timing>
+    <p:tnLst>
+      <p:par>
+        <p:cTn id="1" dur="indefinite" restart="never" nodeType="tmRoot">
+          <p:childTnLst>
+            <p:video>
+              <p:cMediaNode vol="80000">
+                <p:cTn id="2" fill="hold" display="0">
+                  <p:stCondLst>
+                    <p:cond delay="indefinite"/>
+                  </p:stCondLst>
+                </p:cTn>
+                <p:tgtEl>
+                  <p:spTgt spid="14"/>
+                </p:tgtEl>
+              </p:cMediaNode>
+            </p:video>
+          </p:childTnLst>
+        </p:cTn>
+      </p:par>
+    </p:tnLst>
+  </p:timing>
 </p:sld>
 </file>
 
@@ -18739,11 +19764,69 @@
           </a:p>
         </p:txBody>
       </p:sp>
+      <p:pic>
+        <p:nvPicPr>
+          <p:cNvPr id="12" name="slide04.mp3">
+            <a:hlinkClick r:id="" action="ppaction://media"/>
+          </p:cNvPr>
+          <p:cNvPicPr>
+            <a:picLocks noChangeAspect="1"/>
+          </p:cNvPicPr>
+          <p:nvPr>
+            <a:videoFile r:link="rId4"/>
+            <p:extLst>
+              <p:ext uri="{DAA4B4D4-6D71-4841-9C94-3DE7FCFB9230}">
+                <p14:media xmlns:p14="http://schemas.microsoft.com/office/powerpoint/2010/main" r:embed="rId3"/>
+              </p:ext>
+            </p:extLst>
+          </p:nvPr>
+        </p:nvPicPr>
+        <p:blipFill>
+          <a:blip r:embed="rId5"/>
+          <a:stretch>
+            <a:fillRect/>
+          </a:stretch>
+        </p:blipFill>
+        <p:spPr>
+          <a:xfrm>
+            <a:off x="11076127" y="320040"/>
+            <a:ext cx="566928" cy="566928"/>
+          </a:xfrm>
+          <a:prstGeom prst="rect">
+            <a:avLst/>
+          </a:prstGeom>
+          <a:ln>
+            <a:noFill/>
+          </a:ln>
+        </p:spPr>
+      </p:pic>
     </p:spTree>
   </p:cSld>
   <p:clrMapOvr>
     <a:masterClrMapping/>
   </p:clrMapOvr>
+  <p:timing>
+    <p:tnLst>
+      <p:par>
+        <p:cTn id="1" dur="indefinite" restart="never" nodeType="tmRoot">
+          <p:childTnLst>
+            <p:video>
+              <p:cMediaNode vol="80000">
+                <p:cTn id="2" fill="hold" display="0">
+                  <p:stCondLst>
+                    <p:cond delay="indefinite"/>
+                  </p:stCondLst>
+                </p:cTn>
+                <p:tgtEl>
+                  <p:spTgt spid="12"/>
+                </p:tgtEl>
+              </p:cMediaNode>
+            </p:video>
+          </p:childTnLst>
+        </p:cTn>
+      </p:par>
+    </p:tnLst>
+  </p:timing>
 </p:sld>
 </file>
 
@@ -19317,11 +20400,69 @@
           </a:p>
         </p:txBody>
       </p:sp>
+      <p:pic>
+        <p:nvPicPr>
+          <p:cNvPr id="12" name="slide05.mp3">
+            <a:hlinkClick r:id="" action="ppaction://media"/>
+          </p:cNvPr>
+          <p:cNvPicPr>
+            <a:picLocks noChangeAspect="1"/>
+          </p:cNvPicPr>
+          <p:nvPr>
+            <a:videoFile r:link="rId4"/>
+            <p:extLst>
+              <p:ext uri="{DAA4B4D4-6D71-4841-9C94-3DE7FCFB9230}">
+                <p14:media xmlns:p14="http://schemas.microsoft.com/office/powerpoint/2010/main" r:embed="rId3"/>
+              </p:ext>
+            </p:extLst>
+          </p:nvPr>
+        </p:nvPicPr>
+        <p:blipFill>
+          <a:blip r:embed="rId5"/>
+          <a:stretch>
+            <a:fillRect/>
+          </a:stretch>
+        </p:blipFill>
+        <p:spPr>
+          <a:xfrm>
+            <a:off x="11076127" y="320040"/>
+            <a:ext cx="566928" cy="566928"/>
+          </a:xfrm>
+          <a:prstGeom prst="rect">
+            <a:avLst/>
+          </a:prstGeom>
+          <a:ln>
+            <a:noFill/>
+          </a:ln>
+        </p:spPr>
+      </p:pic>
     </p:spTree>
   </p:cSld>
   <p:clrMapOvr>
     <a:masterClrMapping/>
   </p:clrMapOvr>
+  <p:timing>
+    <p:tnLst>
+      <p:par>
+        <p:cTn id="1" dur="indefinite" restart="never" nodeType="tmRoot">
+          <p:childTnLst>
+            <p:video>
+              <p:cMediaNode vol="80000">
+                <p:cTn id="2" fill="hold" display="0">
+                  <p:stCondLst>
+                    <p:cond delay="indefinite"/>
+                  </p:stCondLst>
+                </p:cTn>
+                <p:tgtEl>
+                  <p:spTgt spid="12"/>
+                </p:tgtEl>
+              </p:cMediaNode>
+            </p:video>
+          </p:childTnLst>
+        </p:cTn>
+      </p:par>
+    </p:tnLst>
+  </p:timing>
 </p:sld>
 </file>
 
@@ -19895,11 +21036,69 @@
           </a:p>
         </p:txBody>
       </p:sp>
+      <p:pic>
+        <p:nvPicPr>
+          <p:cNvPr id="12" name="slide06.mp3">
+            <a:hlinkClick r:id="" action="ppaction://media"/>
+          </p:cNvPr>
+          <p:cNvPicPr>
+            <a:picLocks noChangeAspect="1"/>
+          </p:cNvPicPr>
+          <p:nvPr>
+            <a:videoFile r:link="rId4"/>
+            <p:extLst>
+              <p:ext uri="{DAA4B4D4-6D71-4841-9C94-3DE7FCFB9230}">
+                <p14:media xmlns:p14="http://schemas.microsoft.com/office/powerpoint/2010/main" r:embed="rId3"/>
+              </p:ext>
+            </p:extLst>
+          </p:nvPr>
+        </p:nvPicPr>
+        <p:blipFill>
+          <a:blip r:embed="rId5"/>
+          <a:stretch>
+            <a:fillRect/>
+          </a:stretch>
+        </p:blipFill>
+        <p:spPr>
+          <a:xfrm>
+            <a:off x="11076127" y="320040"/>
+            <a:ext cx="566928" cy="566928"/>
+          </a:xfrm>
+          <a:prstGeom prst="rect">
+            <a:avLst/>
+          </a:prstGeom>
+          <a:ln>
+            <a:noFill/>
+          </a:ln>
+        </p:spPr>
+      </p:pic>
     </p:spTree>
   </p:cSld>
   <p:clrMapOvr>
     <a:masterClrMapping/>
   </p:clrMapOvr>
+  <p:timing>
+    <p:tnLst>
+      <p:par>
+        <p:cTn id="1" dur="indefinite" restart="never" nodeType="tmRoot">
+          <p:childTnLst>
+            <p:video>
+              <p:cMediaNode vol="80000">
+                <p:cTn id="2" fill="hold" display="0">
+                  <p:stCondLst>
+                    <p:cond delay="indefinite"/>
+                  </p:stCondLst>
+                </p:cTn>
+                <p:tgtEl>
+                  <p:spTgt spid="12"/>
+                </p:tgtEl>
+              </p:cMediaNode>
+            </p:video>
+          </p:childTnLst>
+        </p:cTn>
+      </p:par>
+    </p:tnLst>
+  </p:timing>
 </p:sld>
 </file>
 
@@ -20497,11 +21696,69 @@
           </a:p>
         </p:txBody>
       </p:sp>
+      <p:pic>
+        <p:nvPicPr>
+          <p:cNvPr id="13" name="slide07.mp3">
+            <a:hlinkClick r:id="" action="ppaction://media"/>
+          </p:cNvPr>
+          <p:cNvPicPr>
+            <a:picLocks noChangeAspect="1"/>
+          </p:cNvPicPr>
+          <p:nvPr>
+            <a:videoFile r:link="rId5"/>
+            <p:extLst>
+              <p:ext uri="{DAA4B4D4-6D71-4841-9C94-3DE7FCFB9230}">
+                <p14:media xmlns:p14="http://schemas.microsoft.com/office/powerpoint/2010/main" r:embed="rId4"/>
+              </p:ext>
+            </p:extLst>
+          </p:nvPr>
+        </p:nvPicPr>
+        <p:blipFill>
+          <a:blip r:embed="rId6"/>
+          <a:stretch>
+            <a:fillRect/>
+          </a:stretch>
+        </p:blipFill>
+        <p:spPr>
+          <a:xfrm>
+            <a:off x="11076127" y="320040"/>
+            <a:ext cx="566928" cy="566928"/>
+          </a:xfrm>
+          <a:prstGeom prst="rect">
+            <a:avLst/>
+          </a:prstGeom>
+          <a:ln>
+            <a:noFill/>
+          </a:ln>
+        </p:spPr>
+      </p:pic>
     </p:spTree>
   </p:cSld>
   <p:clrMapOvr>
     <a:masterClrMapping/>
   </p:clrMapOvr>
+  <p:timing>
+    <p:tnLst>
+      <p:par>
+        <p:cTn id="1" dur="indefinite" restart="never" nodeType="tmRoot">
+          <p:childTnLst>
+            <p:video>
+              <p:cMediaNode vol="80000">
+                <p:cTn id="2" fill="hold" display="0">
+                  <p:stCondLst>
+                    <p:cond delay="indefinite"/>
+                  </p:stCondLst>
+                </p:cTn>
+                <p:tgtEl>
+                  <p:spTgt spid="13"/>
+                </p:tgtEl>
+              </p:cMediaNode>
+            </p:video>
+          </p:childTnLst>
+        </p:cTn>
+      </p:par>
+    </p:tnLst>
+  </p:timing>
 </p:sld>
 </file>
 
@@ -21099,11 +22356,69 @@
           </a:p>
         </p:txBody>
       </p:sp>
+      <p:pic>
+        <p:nvPicPr>
+          <p:cNvPr id="13" name="slide08.mp3">
+            <a:hlinkClick r:id="" action="ppaction://media"/>
+          </p:cNvPr>
+          <p:cNvPicPr>
+            <a:picLocks noChangeAspect="1"/>
+          </p:cNvPicPr>
+          <p:nvPr>
+            <a:videoFile r:link="rId5"/>
+            <p:extLst>
+              <p:ext uri="{DAA4B4D4-6D71-4841-9C94-3DE7FCFB9230}">
+                <p14:media xmlns:p14="http://schemas.microsoft.com/office/powerpoint/2010/main" r:embed="rId4"/>
+              </p:ext>
+            </p:extLst>
+          </p:nvPr>
+        </p:nvPicPr>
+        <p:blipFill>
+          <a:blip r:embed="rId6"/>
+          <a:stretch>
+            <a:fillRect/>
+          </a:stretch>
+        </p:blipFill>
+        <p:spPr>
+          <a:xfrm>
+            <a:off x="11076127" y="320040"/>
+            <a:ext cx="566928" cy="566928"/>
+          </a:xfrm>
+          <a:prstGeom prst="rect">
+            <a:avLst/>
+          </a:prstGeom>
+          <a:ln>
+            <a:noFill/>
+          </a:ln>
+        </p:spPr>
+      </p:pic>
     </p:spTree>
   </p:cSld>
   <p:clrMapOvr>
     <a:masterClrMapping/>
   </p:clrMapOvr>
+  <p:timing>
+    <p:tnLst>
+      <p:par>
+        <p:cTn id="1" dur="indefinite" restart="never" nodeType="tmRoot">
+          <p:childTnLst>
+            <p:video>
+              <p:cMediaNode vol="80000">
+                <p:cTn id="2" fill="hold" display="0">
+                  <p:stCondLst>
+                    <p:cond delay="indefinite"/>
+                  </p:stCondLst>
+                </p:cTn>
+                <p:tgtEl>
+                  <p:spTgt spid="13"/>
+                </p:tgtEl>
+              </p:cMediaNode>
+            </p:video>
+          </p:childTnLst>
+        </p:cTn>
+      </p:par>
+    </p:tnLst>
+  </p:timing>
 </p:sld>
 </file>
 
@@ -21701,11 +23016,69 @@
           </a:p>
         </p:txBody>
       </p:sp>
+      <p:pic>
+        <p:nvPicPr>
+          <p:cNvPr id="13" name="slide09.mp3">
+            <a:hlinkClick r:id="" action="ppaction://media"/>
+          </p:cNvPr>
+          <p:cNvPicPr>
+            <a:picLocks noChangeAspect="1"/>
+          </p:cNvPicPr>
+          <p:nvPr>
+            <a:videoFile r:link="rId5"/>
+            <p:extLst>
+              <p:ext uri="{DAA4B4D4-6D71-4841-9C94-3DE7FCFB9230}">
+                <p14:media xmlns:p14="http://schemas.microsoft.com/office/powerpoint/2010/main" r:embed="rId4"/>
+              </p:ext>
+            </p:extLst>
+          </p:nvPr>
+        </p:nvPicPr>
+        <p:blipFill>
+          <a:blip r:embed="rId6"/>
+          <a:stretch>
+            <a:fillRect/>
+          </a:stretch>
+        </p:blipFill>
+        <p:spPr>
+          <a:xfrm>
+            <a:off x="11076127" y="320040"/>
+            <a:ext cx="566928" cy="566928"/>
+          </a:xfrm>
+          <a:prstGeom prst="rect">
+            <a:avLst/>
+          </a:prstGeom>
+          <a:ln>
+            <a:noFill/>
+          </a:ln>
+        </p:spPr>
+      </p:pic>
     </p:spTree>
   </p:cSld>
   <p:clrMapOvr>
     <a:masterClrMapping/>
   </p:clrMapOvr>
+  <p:timing>
+    <p:tnLst>
+      <p:par>
+        <p:cTn id="1" dur="indefinite" restart="never" nodeType="tmRoot">
+          <p:childTnLst>
+            <p:video>
+              <p:cMediaNode vol="80000">
+                <p:cTn id="2" fill="hold" display="0">
+                  <p:stCondLst>
+                    <p:cond delay="indefinite"/>
+                  </p:stCondLst>
+                </p:cTn>
+                <p:tgtEl>
+                  <p:spTgt spid="13"/>
+                </p:tgtEl>
+              </p:cMediaNode>
+            </p:video>
+          </p:childTnLst>
+        </p:cTn>
+      </p:par>
+    </p:tnLst>
+  </p:timing>
 </p:sld>
 </file>
 

</xml_diff>